<commit_message>
Dark theme for code slides, matching Jim's editor screenshot
Sampled exact colors from the provided screenshot instead of guessing:
- Background: #1D1E22 (near-black, slight blue-gray)
- Keywords (from/import/await/etc.): #A996B6 (muted magenta)
- Strings: #E4C98A (warm gold/tan)
- Comments: #666666, italic
- Default text: #FFFFFF

Added COLORS.codeBg/codeBorder to theme.js; addCode() now fills the code
panel with the dark background and a subtle dark border instead of the
light gray panel used elsewhere in the deck. Only decks/day3 rebuilt -
decks/day1 and decks/day2 share theme.js but were intentionally left
untouched since they've already shipped.

Also picked up two small manual tweaks Jim made directly to
module-1-sessions-state.md (a colon and a capitalization fix).

Co-authored-by: Copilot <223556219+Copilot@users.noreply.github.com>
</commit_message>
<xml_diff>
--- a/decks/day3/module-1-sessions-state.pptx
+++ b/decks/day3/module-1-sessions-state.pptx
@@ -4352,7 +4352,7 @@
                 <a:ea typeface="Calibri" pitchFamily="34" charset="-122"/>
                 <a:cs typeface="Calibri" pitchFamily="34" charset="-120"/>
               </a:rPr>
-              <a:t>What AgentSession contains</a:t>
+              <a:t>What AgentSession contains:</a:t>
             </a:r>
             <a:pPr indent="0" marL="0">
               <a:spcAft>
@@ -4678,11 +4678,11 @@
             <a:avLst/>
           </a:prstGeom>
           <a:solidFill>
-            <a:srgbClr val="F3F4F6"/>
+            <a:srgbClr val="1D1E22"/>
           </a:solidFill>
-          <a:ln w="6350">
+          <a:ln w="9525">
             <a:solidFill>
-              <a:srgbClr val="D1D5DB"/>
+              <a:srgbClr val="2A2B2E"/>
             </a:solidFill>
             <a:prstDash val="solid"/>
           </a:ln>
@@ -4715,7 +4715,7 @@
             <a:r>
               <a:rPr lang="en-US" sz="1280" dirty="0">
                 <a:solidFill>
-                  <a:srgbClr val="1E2761"/>
+                  <a:srgbClr val="A996B6"/>
                 </a:solidFill>
                 <a:latin typeface="Consolas" pitchFamily="34" charset="0"/>
                 <a:ea typeface="Consolas" pitchFamily="34" charset="-122"/>
@@ -4729,7 +4729,7 @@
             <a:r>
               <a:rPr lang="en-US" sz="1280" dirty="0">
                 <a:solidFill>
-                  <a:srgbClr val="212121"/>
+                  <a:srgbClr val="FFFFFF"/>
                 </a:solidFill>
                 <a:latin typeface="Consolas" pitchFamily="34" charset="0"/>
                 <a:ea typeface="Consolas" pitchFamily="34" charset="-122"/>
@@ -4743,7 +4743,7 @@
             <a:r>
               <a:rPr lang="en-US" sz="1280" dirty="0">
                 <a:solidFill>
-                  <a:srgbClr val="1E2761"/>
+                  <a:srgbClr val="A996B6"/>
                 </a:solidFill>
                 <a:latin typeface="Consolas" pitchFamily="34" charset="0"/>
                 <a:ea typeface="Consolas" pitchFamily="34" charset="-122"/>
@@ -4757,7 +4757,7 @@
             <a:r>
               <a:rPr lang="en-US" sz="1280" dirty="0">
                 <a:solidFill>
-                  <a:srgbClr val="212121"/>
+                  <a:srgbClr val="FFFFFF"/>
                 </a:solidFill>
                 <a:latin typeface="Consolas" pitchFamily="34" charset="0"/>
                 <a:ea typeface="Consolas" pitchFamily="34" charset="-122"/>
@@ -4773,7 +4773,7 @@
             <a:r>
               <a:rPr lang="en-US" sz="1280" dirty="0">
                 <a:solidFill>
-                  <a:srgbClr val="1E2761"/>
+                  <a:srgbClr val="A996B6"/>
                 </a:solidFill>
                 <a:latin typeface="Consolas" pitchFamily="34" charset="0"/>
                 <a:ea typeface="Consolas" pitchFamily="34" charset="-122"/>
@@ -4787,7 +4787,7 @@
             <a:r>
               <a:rPr lang="en-US" sz="1280" dirty="0">
                 <a:solidFill>
-                  <a:srgbClr val="212121"/>
+                  <a:srgbClr val="FFFFFF"/>
                 </a:solidFill>
                 <a:latin typeface="Consolas" pitchFamily="34" charset="0"/>
                 <a:ea typeface="Consolas" pitchFamily="34" charset="-122"/>
@@ -4801,7 +4801,7 @@
             <a:r>
               <a:rPr lang="en-US" sz="1280" dirty="0">
                 <a:solidFill>
-                  <a:srgbClr val="1F7A4D"/>
+                  <a:srgbClr val="E4C98A"/>
                 </a:solidFill>
                 <a:latin typeface="Consolas" pitchFamily="34" charset="0"/>
                 <a:ea typeface="Consolas" pitchFamily="34" charset="-122"/>
@@ -4815,7 +4815,7 @@
             <a:r>
               <a:rPr lang="en-US" sz="1280" dirty="0">
                 <a:solidFill>
-                  <a:srgbClr val="212121"/>
+                  <a:srgbClr val="FFFFFF"/>
                 </a:solidFill>
                 <a:latin typeface="Consolas" pitchFamily="34" charset="0"/>
                 <a:ea typeface="Consolas" pitchFamily="34" charset="-122"/>
@@ -4830,7 +4830,7 @@
             <a:r>
               <a:rPr lang="en-US" sz="1280" dirty="0">
                 <a:solidFill>
-                  <a:srgbClr val="1E2761"/>
+                  <a:srgbClr val="A996B6"/>
                 </a:solidFill>
                 <a:latin typeface="Consolas" pitchFamily="34" charset="0"/>
                 <a:ea typeface="Consolas" pitchFamily="34" charset="-122"/>
@@ -4844,7 +4844,7 @@
             <a:r>
               <a:rPr lang="en-US" sz="1280" dirty="0">
                 <a:solidFill>
-                  <a:srgbClr val="212121"/>
+                  <a:srgbClr val="FFFFFF"/>
                 </a:solidFill>
                 <a:latin typeface="Consolas" pitchFamily="34" charset="0"/>
                 <a:ea typeface="Consolas" pitchFamily="34" charset="-122"/>
@@ -4858,7 +4858,7 @@
             <a:r>
               <a:rPr lang="en-US" sz="1280" dirty="0">
                 <a:solidFill>
-                  <a:srgbClr val="1F7A4D"/>
+                  <a:srgbClr val="E4C98A"/>
                 </a:solidFill>
                 <a:latin typeface="Consolas" pitchFamily="34" charset="0"/>
                 <a:ea typeface="Consolas" pitchFamily="34" charset="-122"/>
@@ -4872,7 +4872,7 @@
             <a:r>
               <a:rPr lang="en-US" sz="1280" dirty="0">
                 <a:solidFill>
-                  <a:srgbClr val="212121"/>
+                  <a:srgbClr val="FFFFFF"/>
                 </a:solidFill>
                 <a:latin typeface="Consolas" pitchFamily="34" charset="0"/>
                 <a:ea typeface="Consolas" pitchFamily="34" charset="-122"/>
@@ -4887,7 +4887,7 @@
             <a:r>
               <a:rPr lang="en-US" sz="1280" i="1" dirty="0">
                 <a:solidFill>
-                  <a:srgbClr val="6B7280"/>
+                  <a:srgbClr val="666666"/>
                 </a:solidFill>
                 <a:latin typeface="Consolas" pitchFamily="34" charset="0"/>
                 <a:ea typeface="Consolas" pitchFamily="34" charset="-122"/>
@@ -4901,7 +4901,7 @@
             <a:r>
               <a:rPr lang="en-US" sz="1280" dirty="0">
                 <a:solidFill>
-                  <a:srgbClr val="212121"/>
+                  <a:srgbClr val="FFFFFF"/>
                 </a:solidFill>
                 <a:latin typeface="Consolas" pitchFamily="34" charset="0"/>
                 <a:ea typeface="Consolas" pitchFamily="34" charset="-122"/>
@@ -4917,7 +4917,7 @@
             <a:r>
               <a:rPr lang="en-US" sz="1280" i="1" dirty="0">
                 <a:solidFill>
-                  <a:srgbClr val="6B7280"/>
+                  <a:srgbClr val="666666"/>
                 </a:solidFill>
                 <a:latin typeface="Consolas" pitchFamily="34" charset="0"/>
                 <a:ea typeface="Consolas" pitchFamily="34" charset="-122"/>
@@ -4931,7 +4931,7 @@
             <a:r>
               <a:rPr lang="en-US" sz="1280" dirty="0">
                 <a:solidFill>
-                  <a:srgbClr val="212121"/>
+                  <a:srgbClr val="FFFFFF"/>
                 </a:solidFill>
                 <a:latin typeface="Consolas" pitchFamily="34" charset="0"/>
                 <a:ea typeface="Consolas" pitchFamily="34" charset="-122"/>
@@ -4947,13 +4947,13 @@
             <a:r>
               <a:rPr lang="en-US" sz="1280" i="1" dirty="0">
                 <a:solidFill>
-                  <a:srgbClr val="6B7280"/>
+                  <a:srgbClr val="666666"/>
                 </a:solidFill>
                 <a:latin typeface="Consolas" pitchFamily="34" charset="0"/>
                 <a:ea typeface="Consolas" pitchFamily="34" charset="-122"/>
                 <a:cs typeface="Consolas" pitchFamily="34" charset="-120"/>
               </a:rPr>
-              <a:t># deserialize</a:t>
+              <a:t># Deserialize</a:t>
             </a:r>
             <a:pPr indent="0" marL="0">
               <a:buNone/>
@@ -4967,7 +4967,7 @@
             <a:r>
               <a:rPr lang="en-US" sz="1280" dirty="0">
                 <a:solidFill>
-                  <a:srgbClr val="212121"/>
+                  <a:srgbClr val="FFFFFF"/>
                 </a:solidFill>
                 <a:latin typeface="Consolas" pitchFamily="34" charset="0"/>
                 <a:ea typeface="Consolas" pitchFamily="34" charset="-122"/>

</xml_diff>

<commit_message>
Remove Day 3 Module 1 Demo 3 (suspend/resume)
Jim decided the demo wasn't accomplishing its intended teaching point.
Removed end to end:

- slides/day3/module-1-sessions-state.md: drop the DEMO 1.3 placeholder
  slide between "Storage" and "ContextProvider wraps each invocation"
- demos/day3/module-1-demo-3-suspend-resume.md: runbook deleted
- demos/day3/module-1-demo-3-suspend-resume/: code folder deleted
- demos/day3/README.md: demo count 10->9, roster table, timing math,
  authoring status checklist
- demos/day3/.env.example: remove the now-orphaned OPENAI_API_KEY entry
- demos/day3/pyproject.toml: remove agent-framework-openai (only needed
  by this demo's agent_framework.openai import)

Rebuilt all 9 Day 3 decks; validator passes; Module 1 confirmed 14->13
slides with no gap; verified opens cleanly in real PowerPoint.

Co-authored-by: Copilot <223556219+Copilot@users.noreply.github.com>
</commit_message>
<xml_diff>
--- a/decks/day3/module-1-sessions-state.pptx
+++ b/decks/day3/module-1-sessions-state.pptx
@@ -18,10 +18,9 @@
     <p:sldId id="266" r:id="rId12"/>
     <p:sldId id="267" r:id="rId13"/>
     <p:sldId id="268" r:id="rId14"/>
-    <p:sldId id="269" r:id="rId15"/>
   </p:sldIdLst>
   <p:notesMasterIdLst>
-    <p:notesMasterId r:id="rId16"/>
+    <p:notesMasterId r:id="rId15"/>
   </p:notesMasterIdLst>
   <p:sldSz cx="9144000" cy="5143500"/>
   <p:notesSz cx="5143500" cy="9144000"/>
@@ -604,9 +603,9 @@
           <a:p>
             <a:r>
               <a:rPr lang="en-US" dirty="0"/>
-              <a:t>• This is a Python-specific guardrail, named exactly: "In Python, you can configure multiple history providers, but only one should use load_messages=True." The storage doc adds the companion flag for the observer case — store_context_messages=True — and names the concrete use case: an audit/eval history provider.
-• GROUNDING SOURCE: https://learn.microsoft.com/en-us/agent-framework/concepts/agents/conversations/context-providers?tabs=python
-• GROUNDING SOURCE: https://learn.microsoft.com/en-us/agent-framework/concepts/agents/conversations/storage?tabs=python</a:t>
+              <a:t>• The first three bullets are the storage doc's own "Key guidance" list for a third-party/custom history provider, verbatim. The fourth is a separate, real opt-in flag from the same doc's "Per-service-call local history persistence" section — not previously covered — for keeping local history aligned with a tool-calling loop's multiple model calls. RedisHistoryProvider in the official repo is a concrete example of a trusted store implementing this guidance.
+• GROUNDING SOURCE: https://learn.microsoft.com/en-us/agent-framework/concepts/agents/conversations/storage?tabs=python
+• GROUNDING SOURCE: https://github.com/microsoft/agent-framework/blob/main/python/samples/02-agents/conversations/redis_history_provider.py</a:t>
             </a:r>
             <a:endParaRPr lang="en-US" dirty="0"/>
           </a:p>
@@ -694,9 +693,9 @@
           <a:p>
             <a:r>
               <a:rPr lang="en-US" dirty="0"/>
-              <a:t>• The first three bullets are the storage doc's own "Key guidance" list for a third-party/custom history provider, verbatim. The fourth is a separate, real opt-in flag from the same doc's "Per-service-call local history persistence" section — not previously covered — for keeping local history aligned with a tool-calling loop's multiple model calls. RedisHistoryProvider in the official repo is a concrete example of a trusted store implementing this guidance.
-• GROUNDING SOURCE: https://learn.microsoft.com/en-us/agent-framework/concepts/agents/conversations/storage?tabs=python
-• GROUNDING SOURCE: https://github.com/microsoft/agent-framework/blob/main/python/samples/02-agents/conversations/redis_history_provider.py</a:t>
+              <a:t>• The opening line and the 4-step list are the self-hosting doc's own "Secure session continuation" guidance, verbatim (Python zone). Spend time here. Service IDs may be scoped to one backing project or key, not to each end user — session.md's own OpenAI-specific warning makes the same point about resp_*/conv_* IDs. A multi-tenant app must never accept a raw conversation ID as proof of ownership.
+• GROUNDING SOURCE: https://learn.microsoft.com/en-us/agent-framework/hosting/self-hosting/
+• GROUNDING SOURCE: https://learn.microsoft.com/en-us/agent-framework/concepts/agents/conversations/session?tabs=python</a:t>
             </a:r>
             <a:endParaRPr lang="en-US" dirty="0"/>
           </a:p>
@@ -784,9 +783,9 @@
           <a:p>
             <a:r>
               <a:rPr lang="en-US" dirty="0"/>
-              <a:t>• The opening line and the 4-step list are the self-hosting doc's own "Secure session continuation" guidance, verbatim (Python zone). Spend time here. Service IDs may be scoped to one backing project or key, not to each end user — session.md's own OpenAI-specific warning makes the same point about resp_*/conv_* IDs. A multi-tenant app must never accept a raw conversation ID as proof of ownership.
-• GROUNDING SOURCE: https://learn.microsoft.com/en-us/agent-framework/hosting/self-hosting/
-• GROUNDING SOURCE: https://learn.microsoft.com/en-us/agent-framework/concepts/agents/conversations/session?tabs=python</a:t>
+              <a:t>• Use this as a design review checklist. The answer can combine rows: for example local history plus a custom preference provider plus an application session store. Converted from a table to a list — this five-row matrix is a workshop-authored recap of concepts taught earlier in the module, not a table that appears verbatim in either cited doc. Kept because it adds real value as an end-of-module decision tool, distinct from the Takeaways recap.
+• GROUNDING SOURCE: https://learn.microsoft.com/en-us/agent-framework/concepts/agents/conversations/session?tabs=python
+• GROUNDING SOURCE: https://learn.microsoft.com/en-us/agent-framework/concepts/agents/conversations/context-providers?tabs=python</a:t>
             </a:r>
             <a:endParaRPr lang="en-US" dirty="0"/>
           </a:p>
@@ -874,9 +873,8 @@
           <a:p>
             <a:r>
               <a:rPr lang="en-US" dirty="0"/>
-              <a:t>• Use this as a design review checklist. The answer can combine rows: for example local history plus a custom preference provider plus an application session store. Converted from a table to a list — this five-row matrix is a workshop-authored recap of concepts taught earlier in the module, not a table that appears verbatim in either cited doc. Kept because it adds real value as an end-of-module decision tool, distinct from the Takeaways recap.
-• GROUNDING SOURCE: https://learn.microsoft.com/en-us/agent-framework/concepts/agents/conversations/session?tabs=python
-• GROUNDING SOURCE: https://learn.microsoft.com/en-us/agent-framework/concepts/agents/conversations/context-providers?tabs=python</a:t>
+              <a:t>• Close by asking attendees to name the history owner for their Day 2 assistant. Preview streaming: the same session is passed whether the run returns one response or a stream.
+• GROUNDING SOURCE: https://learn.microsoft.com/en-us/agent-framework/concepts/agents/conversations/session?tabs=python</a:t>
             </a:r>
             <a:endParaRPr lang="en-US" dirty="0"/>
           </a:p>
@@ -900,95 +898,6 @@
             <a:fld id="{F7021451-1387-4CA6-816F-3879F97B5CBC}" type="slidenum">
               <a:rPr lang="en-US"/>
               <a:t>13</a:t>
-            </a:fld>
-            <a:endParaRPr lang="en-US"/>
-          </a:p>
-        </p:txBody>
-      </p:sp>
-    </p:spTree>
-    <p:extLst>
-      <p:ext uri="{BB962C8B-B14F-4D97-AF65-F5344CB8AC3E}">
-        <p14:creationId xmlns:p14="http://schemas.microsoft.com/office/powerpoint/2010/main" val="1024086991"/>
-      </p:ext>
-    </p:extLst>
-  </p:cSld>
-  <p:clrMapOvr>
-    <a:masterClrMapping/>
-  </p:clrMapOvr>
-</p:notes>
-</file>
-
-<file path=ppt/notesSlides/notesSlide14.xml><?xml version="1.0" encoding="utf-8"?>
-<p:notes xmlns:a="http://schemas.openxmlformats.org/drawingml/2006/main" xmlns:r="http://schemas.openxmlformats.org/officeDocument/2006/relationships" xmlns:p="http://schemas.openxmlformats.org/presentationml/2006/main">
-  <p:cSld>
-    <p:spTree>
-      <p:nvGrpSpPr>
-        <p:cNvPr id="1" name=""/>
-        <p:cNvGrpSpPr/>
-        <p:nvPr/>
-      </p:nvGrpSpPr>
-      <p:grpSpPr>
-        <a:xfrm>
-          <a:off x="0" y="0"/>
-          <a:ext cx="0" cy="0"/>
-          <a:chOff x="0" y="0"/>
-          <a:chExt cx="0" cy="0"/>
-        </a:xfrm>
-      </p:grpSpPr>
-      <p:sp>
-        <p:nvSpPr>
-          <p:cNvPr id="2" name="Slide Image Placeholder 1"/>
-          <p:cNvSpPr>
-            <a:spLocks noGrp="1" noRot="1" noChangeAspect="1"/>
-          </p:cNvSpPr>
-          <p:nvPr>
-            <p:ph type="sldImg"/>
-          </p:nvPr>
-        </p:nvSpPr>
-        <p:spPr/>
-      </p:sp>
-      <p:sp>
-        <p:nvSpPr>
-          <p:cNvPr id="3" name="Notes Placeholder 2"/>
-          <p:cNvSpPr>
-            <a:spLocks noGrp="1"/>
-          </p:cNvSpPr>
-          <p:nvPr>
-            <p:ph type="body" idx="1"/>
-          </p:nvPr>
-        </p:nvSpPr>
-        <p:spPr/>
-        <p:txBody>
-          <a:bodyPr/>
-          <a:lstStyle/>
-          <a:p>
-            <a:r>
-              <a:rPr lang="en-US" dirty="0"/>
-              <a:t>• Close by asking attendees to name the history owner for their Day 2 assistant. Preview streaming: the same session is passed whether the run returns one response or a stream.
-• GROUNDING SOURCE: https://learn.microsoft.com/en-us/agent-framework/concepts/agents/conversations/session?tabs=python</a:t>
-            </a:r>
-            <a:endParaRPr lang="en-US" dirty="0"/>
-          </a:p>
-        </p:txBody>
-      </p:sp>
-      <p:sp>
-        <p:nvSpPr>
-          <p:cNvPr id="4" name="Slide Number Placeholder 3"/>
-          <p:cNvSpPr>
-            <a:spLocks noGrp="1"/>
-          </p:cNvSpPr>
-          <p:nvPr>
-            <p:ph type="sldNum" sz="quarter" idx="10"/>
-          </p:nvPr>
-        </p:nvSpPr>
-        <p:spPr/>
-        <p:txBody>
-          <a:bodyPr/>
-          <a:lstStyle/>
-          <a:p>
-            <a:fld id="{F7021451-1387-4CA6-816F-3879F97B5CBC}" type="slidenum">
-              <a:rPr lang="en-US"/>
-              <a:t>14</a:t>
             </a:fld>
             <a:endParaRPr lang="en-US"/>
           </a:p>
@@ -1592,8 +1501,8 @@
           <a:p>
             <a:r>
               <a:rPr lang="en-US" dirty="0"/>
-              <a:t>• Placeholder marker slide — the runbook has full narration, setup, and fallback plan. Runs the official suspend_resume_session.py sample as-is; no adaptation.
-• GROUNDING SOURCE: https://github.com/microsoft/agent-framework/blob/main/python/samples/02-agents/conversations/suspend_resume_session.py</a:t>
+              <a:t>• Name the actual Python methods instead of the generic "enriches SessionContext" — extend_instructions, extend_tools, and extend_middleware are the doc's own API surface for before_run. Keep per-session state in the session, not on a provider instance shared by users — the provider instance is shared across every session.
+• GROUNDING SOURCE: https://learn.microsoft.com/en-us/agent-framework/concepts/agents/conversations/context-providers?tabs=python</a:t>
             </a:r>
             <a:endParaRPr lang="en-US" dirty="0"/>
           </a:p>
@@ -1681,8 +1590,9 @@
           <a:p>
             <a:r>
               <a:rPr lang="en-US" dirty="0"/>
-              <a:t>• Name the actual Python methods instead of the generic "enriches SessionContext" — extend_instructions, extend_tools, and extend_middleware are the doc's own API surface for before_run. Keep per-session state in the session, not on a provider instance shared by users — the provider instance is shared across every session.
-• GROUNDING SOURCE: https://learn.microsoft.com/en-us/agent-framework/concepts/agents/conversations/context-providers?tabs=python</a:t>
+              <a:t>• This is a Python-specific guardrail, named exactly: "In Python, you can configure multiple history providers, but only one should use load_messages=True." The storage doc adds the companion flag for the observer case — store_context_messages=True — and names the concrete use case: an audit/eval history provider.
+• GROUNDING SOURCE: https://learn.microsoft.com/en-us/agent-framework/concepts/agents/conversations/context-providers?tabs=python
+• GROUNDING SOURCE: https://learn.microsoft.com/en-us/agent-framework/concepts/agents/conversations/storage?tabs=python</a:t>
             </a:r>
             <a:endParaRPr lang="en-US" dirty="0"/>
           </a:p>
@@ -2395,7 +2305,7 @@
               <a:buNone/>
             </a:pPr>
             <a:r>
-              <a:rPr lang="en-US" sz="2800" b="1" dirty="0">
+              <a:rPr lang="en-US" sz="2500" b="1" dirty="0">
                 <a:solidFill>
                   <a:srgbClr val="1E2761"/>
                 </a:solidFill>
@@ -2403,9 +2313,9 @@
                 <a:ea typeface="Calibri" pitchFamily="34" charset="-122"/>
                 <a:cs typeface="Calibri" pitchFamily="34" charset="-120"/>
               </a:rPr>
-              <a:t>One provider loads messages</a:t>
-            </a:r>
-            <a:endParaRPr lang="en-US" sz="2800" dirty="0"/>
+              <a:t>Durability is an application choice</a:t>
+            </a:r>
+            <a:endParaRPr lang="en-US" sz="2500" dirty="0"/>
           </a:p>
         </p:txBody>
       </p:sp>
@@ -2448,7 +2358,7 @@
                 <a:ea typeface="Calibri" pitchFamily="34" charset="-122"/>
                 <a:cs typeface="Calibri" pitchFamily="34" charset="-120"/>
               </a:rPr>
-              <a:t>Loader</a:t>
+              <a:t>Store messages under a session-scoped key</a:t>
             </a:r>
             <a:pPr indent="0" marL="0">
               <a:spcAft>
@@ -2465,7 +2375,7 @@
                 <a:ea typeface="Calibri" pitchFamily="34" charset="-122"/>
                 <a:cs typeface="Calibri" pitchFamily="34" charset="-120"/>
               </a:rPr>
-              <a:t>  —  Exactly one HistoryProvider is configured with load_messages=True</a:t>
+              <a:t>  —  one session's history shouldn't leak into another's</a:t>
             </a:r>
             <a:endParaRPr lang="en-US" sz="1600" dirty="0"/>
           </a:p>
@@ -2486,7 +2396,7 @@
                 <a:ea typeface="Calibri" pitchFamily="34" charset="-122"/>
                 <a:cs typeface="Calibri" pitchFamily="34" charset="-120"/>
               </a:rPr>
-              <a:t>Observers</a:t>
+              <a:t>Keep returned history within model context limits</a:t>
             </a:r>
             <a:pPr indent="0" marL="0">
               <a:spcAft>
@@ -2503,7 +2413,7 @@
                 <a:ea typeface="Calibri" pitchFamily="34" charset="-122"/>
                 <a:cs typeface="Calibri" pitchFamily="34" charset="-120"/>
               </a:rPr>
-              <a:t>  —  Additional history providers use load_messages=False; set store_context_messages=True so they still capture context from other providers alongside input/output</a:t>
+              <a:t>  —  apply a compaction strategy (Module 3) or a reducer if it grows too large</a:t>
             </a:r>
             <a:endParaRPr lang="en-US" sz="1600" dirty="0"/>
           </a:p>
@@ -2524,7 +2434,7 @@
                 <a:ea typeface="Calibri" pitchFamily="34" charset="-122"/>
                 <a:cs typeface="Calibri" pitchFamily="34" charset="-120"/>
               </a:rPr>
-              <a:t>Why one loader</a:t>
+              <a:t>Persist provider-specific identifiers in the session state</a:t>
             </a:r>
             <a:pPr indent="0" marL="0">
               <a:spcAft>
@@ -2541,7 +2451,7 @@
                 <a:ea typeface="Calibri" pitchFamily="34" charset="-122"/>
                 <a:cs typeface="Calibri" pitchFamily="34" charset="-120"/>
               </a:rPr>
-              <a:t>  —  Two loaders can duplicate history and distort what the model sees</a:t>
+              <a:t>  —  not as a side-channel your app has to track by hand</a:t>
             </a:r>
             <a:endParaRPr lang="en-US" sz="1600" dirty="0"/>
           </a:p>
@@ -2562,7 +2472,7 @@
                 <a:ea typeface="Calibri" pitchFamily="34" charset="-122"/>
                 <a:cs typeface="Calibri" pitchFamily="34" charset="-120"/>
               </a:rPr>
-              <a:t>Typical use</a:t>
+              <a:t>Per-service-call persistence is opt-in</a:t>
             </a:r>
             <a:pPr indent="0" marL="0">
               <a:spcAft>
@@ -2579,7 +2489,7 @@
                 <a:ea typeface="Calibri" pitchFamily="34" charset="-122"/>
                 <a:cs typeface="Calibri" pitchFamily="34" charset="-120"/>
               </a:rPr>
-              <a:t>  —  An audit/eval history provider that observes without affecting primary history loading</a:t>
+              <a:t>  —  require_per_service_call_history_persistence=True runs local history providers around every model call inside a tool loop, not just once after the full agent.run() completes</a:t>
             </a:r>
             <a:endParaRPr lang="en-US" sz="1600" dirty="0"/>
           </a:p>
@@ -2643,7 +2553,7 @@
                 <a:ea typeface="Calibri" pitchFamily="34" charset="-122"/>
                 <a:cs typeface="Calibri" pitchFamily="34" charset="-120"/>
               </a:rPr>
-              <a:t>Source: https://learn.microsoft.com/en-us/agent-framework/concepts/agents/conversations/context-providers?tabs=python  ·  +1 in notes</a:t>
+              <a:t>Source: https://learn.microsoft.com/en-us/agent-framework/concepts/agents/conversations/storage?tabs=python  ·  +1 in notes</a:t>
             </a:r>
             <a:endParaRPr lang="en-US" sz="820" dirty="0"/>
           </a:p>
@@ -2769,7 +2679,7 @@
               <a:buNone/>
             </a:pPr>
             <a:r>
-              <a:rPr lang="en-US" sz="2500" b="1" dirty="0">
+              <a:rPr lang="en-US" sz="2300" b="1" dirty="0">
                 <a:solidFill>
                   <a:srgbClr val="1E2761"/>
                 </a:solidFill>
@@ -2777,9 +2687,9 @@
                 <a:ea typeface="Calibri" pitchFamily="34" charset="-122"/>
                 <a:cs typeface="Calibri" pitchFamily="34" charset="-120"/>
               </a:rPr>
-              <a:t>Durability is an application choice</a:t>
-            </a:r>
-            <a:endParaRPr lang="en-US" sz="2500" dirty="0"/>
+              <a:t>A service conversation ID is not authorization</a:t>
+            </a:r>
+            <a:endParaRPr lang="en-US" sz="2300" dirty="0"/>
           </a:p>
         </p:txBody>
       </p:sp>
@@ -2822,7 +2732,7 @@
                 <a:ea typeface="Calibri" pitchFamily="34" charset="-122"/>
                 <a:cs typeface="Calibri" pitchFamily="34" charset="-120"/>
               </a:rPr>
-              <a:t>Store messages under a session-scoped key</a:t>
+              <a:t>Not proof of ownership</a:t>
             </a:r>
             <a:pPr indent="0" marL="0">
               <a:spcAft>
@@ -2839,7 +2749,7 @@
                 <a:ea typeface="Calibri" pitchFamily="34" charset="-122"/>
                 <a:cs typeface="Calibri" pitchFamily="34" charset="-120"/>
               </a:rPr>
-              <a:t>  —  one session's history shouldn't leak into another's</a:t>
+              <a:t>  —  "A continuation ID identifies a session to resume; it doesn't prove that the caller owns that session."</a:t>
             </a:r>
             <a:endParaRPr lang="en-US" sz="1600" dirty="0"/>
           </a:p>
@@ -2860,24 +2770,7 @@
                 <a:ea typeface="Calibri" pitchFamily="34" charset="-122"/>
                 <a:cs typeface="Calibri" pitchFamily="34" charset="-120"/>
               </a:rPr>
-              <a:t>Keep returned history within model context limits</a:t>
-            </a:r>
-            <a:pPr indent="0" marL="0">
-              <a:spcAft>
-                <a:spcPts val="1000"/>
-              </a:spcAft>
-              <a:buNone/>
-            </a:pPr>
-            <a:r>
-              <a:rPr lang="en-US" sz="1600" dirty="0">
-                <a:solidFill>
-                  <a:srgbClr val="212121"/>
-                </a:solidFill>
-                <a:latin typeface="Calibri" pitchFamily="34" charset="0"/>
-                <a:ea typeface="Calibri" pitchFamily="34" charset="-122"/>
-                <a:cs typeface="Calibri" pitchFamily="34" charset="-120"/>
-              </a:rPr>
-              <a:t>  —  apply a compaction strategy (Module 3) or a reducer if it grows too large</a:t>
+              <a:t>1. Authenticate the caller</a:t>
             </a:r>
             <a:endParaRPr lang="en-US" sz="1600" dirty="0"/>
           </a:p>
@@ -2898,24 +2791,7 @@
                 <a:ea typeface="Calibri" pitchFamily="34" charset="-122"/>
                 <a:cs typeface="Calibri" pitchFamily="34" charset="-120"/>
               </a:rPr>
-              <a:t>Persist provider-specific identifiers in the session state</a:t>
-            </a:r>
-            <a:pPr indent="0" marL="0">
-              <a:spcAft>
-                <a:spcPts val="1000"/>
-              </a:spcAft>
-              <a:buNone/>
-            </a:pPr>
-            <a:r>
-              <a:rPr lang="en-US" sz="1600" dirty="0">
-                <a:solidFill>
-                  <a:srgbClr val="212121"/>
-                </a:solidFill>
-                <a:latin typeface="Calibri" pitchFamily="34" charset="0"/>
-                <a:ea typeface="Calibri" pitchFamily="34" charset="-122"/>
-                <a:cs typeface="Calibri" pitchFamily="34" charset="-120"/>
-              </a:rPr>
-              <a:t>  —  not as a side-channel your app has to track by hand</a:t>
+              <a:t>2. Authorize the caller to access the referenced state</a:t>
             </a:r>
             <a:endParaRPr lang="en-US" sz="1600" dirty="0"/>
           </a:p>
@@ -2936,24 +2812,28 @@
                 <a:ea typeface="Calibri" pitchFamily="34" charset="-122"/>
                 <a:cs typeface="Calibri" pitchFamily="34" charset="-120"/>
               </a:rPr>
-              <a:t>Per-service-call persistence is opt-in</a:t>
-            </a:r>
-            <a:pPr indent="0" marL="0">
+              <a:t>3. Partition durable state by the authenticated tenant, user, or workspace</a:t>
+            </a:r>
+            <a:endParaRPr lang="en-US" sz="1600" dirty="0"/>
+          </a:p>
+          <a:p>
+            <a:pPr marL="342900" indent="-342900">
               <a:spcAft>
                 <a:spcPts val="1000"/>
               </a:spcAft>
-              <a:buNone/>
-            </a:pPr>
-            <a:r>
-              <a:rPr lang="en-US" sz="1600" dirty="0">
-                <a:solidFill>
-                  <a:srgbClr val="212121"/>
-                </a:solidFill>
-                <a:latin typeface="Calibri" pitchFamily="34" charset="0"/>
-                <a:ea typeface="Calibri" pitchFamily="34" charset="-122"/>
-                <a:cs typeface="Calibri" pitchFamily="34" charset="-120"/>
-              </a:rPr>
-              <a:t>  —  require_per_service_call_history_persistence=True runs local history providers around every model call inside a tool loop, not just once after the full agent.run() completes</a:t>
+              <a:buSzPct val="100000"/>
+              <a:buChar char="•"/>
+            </a:pPr>
+            <a:r>
+              <a:rPr lang="en-US" sz="1600" b="1" dirty="0">
+                <a:solidFill>
+                  <a:srgbClr val="1E2761"/>
+                </a:solidFill>
+                <a:latin typeface="Calibri" pitchFamily="34" charset="0"/>
+                <a:ea typeface="Calibri" pitchFamily="34" charset="-122"/>
+                <a:cs typeface="Calibri" pitchFamily="34" charset="-120"/>
+              </a:rPr>
+              <a:t>4. Persist session and checkpoint state only after the run or stream has completed</a:t>
             </a:r>
             <a:endParaRPr lang="en-US" sz="1600" dirty="0"/>
           </a:p>
@@ -3017,7 +2897,7 @@
                 <a:ea typeface="Calibri" pitchFamily="34" charset="-122"/>
                 <a:cs typeface="Calibri" pitchFamily="34" charset="-120"/>
               </a:rPr>
-              <a:t>Source: https://learn.microsoft.com/en-us/agent-framework/concepts/agents/conversations/storage?tabs=python  ·  +1 in notes</a:t>
+              <a:t>Source: https://learn.microsoft.com/en-us/agent-framework/hosting/self-hosting/  ·  +1 in notes</a:t>
             </a:r>
             <a:endParaRPr lang="en-US" sz="820" dirty="0"/>
           </a:p>
@@ -3143,7 +3023,7 @@
               <a:buNone/>
             </a:pPr>
             <a:r>
-              <a:rPr lang="en-US" sz="2300" b="1" dirty="0">
+              <a:rPr lang="en-US" sz="2800" b="1" dirty="0">
                 <a:solidFill>
                   <a:srgbClr val="1E2761"/>
                 </a:solidFill>
@@ -3151,9 +3031,9 @@
                 <a:ea typeface="Calibri" pitchFamily="34" charset="-122"/>
                 <a:cs typeface="Calibri" pitchFamily="34" charset="-120"/>
               </a:rPr>
-              <a:t>A service conversation ID is not authorization</a:t>
-            </a:r>
-            <a:endParaRPr lang="en-US" sz="2300" dirty="0"/>
+              <a:t>Decision guide</a:t>
+            </a:r>
+            <a:endParaRPr lang="en-US" sz="2800" dirty="0"/>
           </a:p>
         </p:txBody>
       </p:sp>
@@ -3196,7 +3076,7 @@
                 <a:ea typeface="Calibri" pitchFamily="34" charset="-122"/>
                 <a:cs typeface="Calibri" pitchFamily="34" charset="-120"/>
               </a:rPr>
-              <a:t>Not proof of ownership</a:t>
+              <a:t>Short-lived local chat</a:t>
             </a:r>
             <a:pPr indent="0" marL="0">
               <a:spcAft>
@@ -3213,7 +3093,7 @@
                 <a:ea typeface="Calibri" pitchFamily="34" charset="-122"/>
                 <a:cs typeface="Calibri" pitchFamily="34" charset="-120"/>
               </a:rPr>
-              <a:t>  —  "A continuation ID identifies a session to resume; it doesn't prove that the caller owns that session."</a:t>
+              <a:t>  —  InMemoryHistoryProvider; verify process loss is acceptable</a:t>
             </a:r>
             <a:endParaRPr lang="en-US" sz="1600" dirty="0"/>
           </a:p>
@@ -3234,7 +3114,24 @@
                 <a:ea typeface="Calibri" pitchFamily="34" charset="-122"/>
                 <a:cs typeface="Calibri" pitchFamily="34" charset="-120"/>
               </a:rPr>
-              <a:t>1. Authenticate the caller</a:t>
+              <a:t>Server-side conversation</a:t>
+            </a:r>
+            <a:pPr indent="0" marL="0">
+              <a:spcAft>
+                <a:spcPts val="1000"/>
+              </a:spcAft>
+              <a:buNone/>
+            </a:pPr>
+            <a:r>
+              <a:rPr lang="en-US" sz="1600" dirty="0">
+                <a:solidFill>
+                  <a:srgbClr val="212121"/>
+                </a:solidFill>
+                <a:latin typeface="Calibri" pitchFamily="34" charset="0"/>
+                <a:ea typeface="Calibri" pitchFamily="34" charset="-122"/>
+                <a:cs typeface="Calibri" pitchFamily="34" charset="-120"/>
+              </a:rPr>
+              <a:t>  —  Service-managed session; verify the service and provider both support it</a:t>
             </a:r>
             <a:endParaRPr lang="en-US" sz="1600" dirty="0"/>
           </a:p>
@@ -3255,7 +3152,24 @@
                 <a:ea typeface="Calibri" pitchFamily="34" charset="-122"/>
                 <a:cs typeface="Calibri" pitchFamily="34" charset="-120"/>
               </a:rPr>
-              <a:t>2. Authorize the caller to access the referenced state</a:t>
+              <a:t>Dynamic memory or policy</a:t>
+            </a:r>
+            <a:pPr indent="0" marL="0">
+              <a:spcAft>
+                <a:spcPts val="1000"/>
+              </a:spcAft>
+              <a:buNone/>
+            </a:pPr>
+            <a:r>
+              <a:rPr lang="en-US" sz="1600" dirty="0">
+                <a:solidFill>
+                  <a:srgbClr val="212121"/>
+                </a:solidFill>
+                <a:latin typeface="Calibri" pitchFamily="34" charset="0"/>
+                <a:ea typeface="Calibri" pitchFamily="34" charset="-122"/>
+                <a:cs typeface="Calibri" pitchFamily="34" charset="-120"/>
+              </a:rPr>
+              <a:t>  —  ContextProvider; verify before_run/after_run state is session-scoped</a:t>
             </a:r>
             <a:endParaRPr lang="en-US" sz="1600" dirty="0"/>
           </a:p>
@@ -3276,7 +3190,24 @@
                 <a:ea typeface="Calibri" pitchFamily="34" charset="-122"/>
                 <a:cs typeface="Calibri" pitchFamily="34" charset="-120"/>
               </a:rPr>
-              <a:t>3. Partition durable state by the authenticated tenant, user, or workspace</a:t>
+              <a:t>Restart durability</a:t>
+            </a:r>
+            <a:pPr indent="0" marL="0">
+              <a:spcAft>
+                <a:spcPts val="1000"/>
+              </a:spcAft>
+              <a:buNone/>
+            </a:pPr>
+            <a:r>
+              <a:rPr lang="en-US" sz="1600" dirty="0">
+                <a:solidFill>
+                  <a:srgbClr val="212121"/>
+                </a:solidFill>
+                <a:latin typeface="Calibri" pitchFamily="34" charset="0"/>
+                <a:ea typeface="Calibri" pitchFamily="34" charset="-122"/>
+                <a:cs typeface="Calibri" pitchFamily="34" charset="-120"/>
+              </a:rPr>
+              <a:t>  —  App-owned persistence, or a self-host SessionStore; verify encryption, retention, and concurrency</a:t>
             </a:r>
             <a:endParaRPr lang="en-US" sz="1600" dirty="0"/>
           </a:p>
@@ -3297,7 +3228,24 @@
                 <a:ea typeface="Calibri" pitchFamily="34" charset="-122"/>
                 <a:cs typeface="Calibri" pitchFamily="34" charset="-120"/>
               </a:rPr>
-              <a:t>4. Persist session and checkpoint state only after the run or stream has completed</a:t>
+              <a:t>Multi-tenant resume</a:t>
+            </a:r>
+            <a:pPr indent="0" marL="0">
+              <a:spcAft>
+                <a:spcPts val="1000"/>
+              </a:spcAft>
+              <a:buNone/>
+            </a:pPr>
+            <a:r>
+              <a:rPr lang="en-US" sz="1600" dirty="0">
+                <a:solidFill>
+                  <a:srgbClr val="212121"/>
+                </a:solidFill>
+                <a:latin typeface="Calibri" pitchFamily="34" charset="0"/>
+                <a:ea typeface="Calibri" pitchFamily="34" charset="-122"/>
+                <a:cs typeface="Calibri" pitchFamily="34" charset="-120"/>
+              </a:rPr>
+              <a:t>  —  A trusted ownership mapping; verify raw service IDs are never treated as authorization</a:t>
             </a:r>
             <a:endParaRPr lang="en-US" sz="1600" dirty="0"/>
           </a:p>
@@ -3361,7 +3309,7 @@
                 <a:ea typeface="Calibri" pitchFamily="34" charset="-122"/>
                 <a:cs typeface="Calibri" pitchFamily="34" charset="-120"/>
               </a:rPr>
-              <a:t>Source: https://learn.microsoft.com/en-us/agent-framework/hosting/self-hosting/  ·  +1 in notes</a:t>
+              <a:t>Source: https://learn.microsoft.com/en-us/agent-framework/concepts/agents/conversations/session?tabs=python  ·  +1 in notes</a:t>
             </a:r>
             <a:endParaRPr lang="en-US" sz="820" dirty="0"/>
           </a:p>
@@ -3378,418 +3326,6 @@
 <file path=ppt/slides/slide13.xml><?xml version="1.0" encoding="utf-8"?>
 <p:sld xmlns:a="http://schemas.openxmlformats.org/drawingml/2006/main" xmlns:r="http://schemas.openxmlformats.org/officeDocument/2006/relationships" xmlns:p="http://schemas.openxmlformats.org/presentationml/2006/main">
   <p:cSld name="Slide 13">
-    <p:bg>
-      <p:bgPr>
-        <a:solidFill>
-          <a:srgbClr val="FFFFFF"/>
-        </a:solidFill>
-      </p:bgPr>
-    </p:bg>
-    <p:spTree>
-      <p:nvGrpSpPr>
-        <p:cNvPr id="1" name=""/>
-        <p:cNvGrpSpPr/>
-        <p:nvPr/>
-      </p:nvGrpSpPr>
-      <p:grpSpPr>
-        <a:xfrm>
-          <a:off x="0" y="0"/>
-          <a:ext cx="0" cy="0"/>
-          <a:chOff x="0" y="0"/>
-          <a:chExt cx="0" cy="0"/>
-        </a:xfrm>
-      </p:grpSpPr>
-      <p:sp>
-        <p:nvSpPr>
-          <p:cNvPr id="2" name="Shape 0"/>
-          <p:cNvSpPr/>
-          <p:nvPr/>
-        </p:nvSpPr>
-        <p:spPr>
-          <a:xfrm>
-            <a:off x="0" y="0"/>
-            <a:ext cx="54864" cy="5143500"/>
-          </a:xfrm>
-          <a:prstGeom prst="rect">
-            <a:avLst/>
-          </a:prstGeom>
-          <a:solidFill>
-            <a:srgbClr val="1E2761"/>
-          </a:solidFill>
-          <a:ln/>
-        </p:spPr>
-      </p:sp>
-      <p:sp>
-        <p:nvSpPr>
-          <p:cNvPr id="3" name="Text 1"/>
-          <p:cNvSpPr/>
-          <p:nvPr/>
-        </p:nvSpPr>
-        <p:spPr>
-          <a:xfrm>
-            <a:off x="5486400" y="256032"/>
-            <a:ext cx="3337560" cy="228600"/>
-          </a:xfrm>
-          <a:prstGeom prst="rect">
-            <a:avLst/>
-          </a:prstGeom>
-          <a:noFill/>
-          <a:ln/>
-        </p:spPr>
-        <p:txBody>
-          <a:bodyPr wrap="square" lIns="0" tIns="0" rIns="0" bIns="0" rtlCol="0" anchor="ctr">
-            <a:normAutofit/>
-          </a:bodyPr>
-          <a:lstStyle/>
-          <a:p>
-            <a:pPr algn="r" indent="0" marL="0">
-              <a:buNone/>
-            </a:pPr>
-            <a:r>
-              <a:rPr lang="en-US" sz="950" dirty="0">
-                <a:solidFill>
-                  <a:srgbClr val="6B7280"/>
-                </a:solidFill>
-                <a:latin typeface="Calibri" pitchFamily="34" charset="0"/>
-                <a:ea typeface="Calibri" pitchFamily="34" charset="-122"/>
-                <a:cs typeface="Calibri" pitchFamily="34" charset="-120"/>
-              </a:rPr>
-              <a:t>Day 3 · Module 1</a:t>
-            </a:r>
-            <a:endParaRPr lang="en-US" sz="950" dirty="0"/>
-          </a:p>
-        </p:txBody>
-      </p:sp>
-      <p:sp>
-        <p:nvSpPr>
-          <p:cNvPr id="4" name="Text 2"/>
-          <p:cNvSpPr/>
-          <p:nvPr/>
-        </p:nvSpPr>
-        <p:spPr>
-          <a:xfrm>
-            <a:off x="365760" y="310896"/>
-            <a:ext cx="6583680" cy="603504"/>
-          </a:xfrm>
-          <a:prstGeom prst="rect">
-            <a:avLst/>
-          </a:prstGeom>
-          <a:noFill/>
-          <a:ln/>
-        </p:spPr>
-        <p:txBody>
-          <a:bodyPr wrap="square" lIns="0" tIns="0" rIns="0" bIns="0" rtlCol="0" anchor="ctr">
-            <a:normAutofit/>
-          </a:bodyPr>
-          <a:lstStyle/>
-          <a:p>
-            <a:pPr indent="0" marL="0">
-              <a:buNone/>
-            </a:pPr>
-            <a:r>
-              <a:rPr lang="en-US" sz="2800" b="1" dirty="0">
-                <a:solidFill>
-                  <a:srgbClr val="1E2761"/>
-                </a:solidFill>
-                <a:latin typeface="Calibri" pitchFamily="34" charset="0"/>
-                <a:ea typeface="Calibri" pitchFamily="34" charset="-122"/>
-                <a:cs typeface="Calibri" pitchFamily="34" charset="-120"/>
-              </a:rPr>
-              <a:t>Decision guide</a:t>
-            </a:r>
-            <a:endParaRPr lang="en-US" sz="2800" dirty="0"/>
-          </a:p>
-        </p:txBody>
-      </p:sp>
-      <p:sp>
-        <p:nvSpPr>
-          <p:cNvPr id="5" name="Text 3"/>
-          <p:cNvSpPr/>
-          <p:nvPr/>
-        </p:nvSpPr>
-        <p:spPr>
-          <a:xfrm>
-            <a:off x="502920" y="1170432"/>
-            <a:ext cx="7955280" cy="3520440"/>
-          </a:xfrm>
-          <a:prstGeom prst="rect">
-            <a:avLst/>
-          </a:prstGeom>
-          <a:noFill/>
-          <a:ln/>
-        </p:spPr>
-        <p:txBody>
-          <a:bodyPr wrap="square" lIns="0" tIns="0" rIns="0" bIns="0" rtlCol="0" anchor="t">
-            <a:normAutofit/>
-          </a:bodyPr>
-          <a:lstStyle/>
-          <a:p>
-            <a:pPr marL="342900" indent="-342900">
-              <a:spcAft>
-                <a:spcPts val="1000"/>
-              </a:spcAft>
-              <a:buSzPct val="100000"/>
-              <a:buChar char="•"/>
-            </a:pPr>
-            <a:r>
-              <a:rPr lang="en-US" sz="1600" b="1" dirty="0">
-                <a:solidFill>
-                  <a:srgbClr val="1E2761"/>
-                </a:solidFill>
-                <a:latin typeface="Calibri" pitchFamily="34" charset="0"/>
-                <a:ea typeface="Calibri" pitchFamily="34" charset="-122"/>
-                <a:cs typeface="Calibri" pitchFamily="34" charset="-120"/>
-              </a:rPr>
-              <a:t>Short-lived local chat</a:t>
-            </a:r>
-            <a:pPr indent="0" marL="0">
-              <a:spcAft>
-                <a:spcPts val="1000"/>
-              </a:spcAft>
-              <a:buNone/>
-            </a:pPr>
-            <a:r>
-              <a:rPr lang="en-US" sz="1600" dirty="0">
-                <a:solidFill>
-                  <a:srgbClr val="212121"/>
-                </a:solidFill>
-                <a:latin typeface="Calibri" pitchFamily="34" charset="0"/>
-                <a:ea typeface="Calibri" pitchFamily="34" charset="-122"/>
-                <a:cs typeface="Calibri" pitchFamily="34" charset="-120"/>
-              </a:rPr>
-              <a:t>  —  InMemoryHistoryProvider; verify process loss is acceptable</a:t>
-            </a:r>
-            <a:endParaRPr lang="en-US" sz="1600" dirty="0"/>
-          </a:p>
-          <a:p>
-            <a:pPr marL="342900" indent="-342900">
-              <a:spcAft>
-                <a:spcPts val="1000"/>
-              </a:spcAft>
-              <a:buSzPct val="100000"/>
-              <a:buChar char="•"/>
-            </a:pPr>
-            <a:r>
-              <a:rPr lang="en-US" sz="1600" b="1" dirty="0">
-                <a:solidFill>
-                  <a:srgbClr val="1E2761"/>
-                </a:solidFill>
-                <a:latin typeface="Calibri" pitchFamily="34" charset="0"/>
-                <a:ea typeface="Calibri" pitchFamily="34" charset="-122"/>
-                <a:cs typeface="Calibri" pitchFamily="34" charset="-120"/>
-              </a:rPr>
-              <a:t>Server-side conversation</a:t>
-            </a:r>
-            <a:pPr indent="0" marL="0">
-              <a:spcAft>
-                <a:spcPts val="1000"/>
-              </a:spcAft>
-              <a:buNone/>
-            </a:pPr>
-            <a:r>
-              <a:rPr lang="en-US" sz="1600" dirty="0">
-                <a:solidFill>
-                  <a:srgbClr val="212121"/>
-                </a:solidFill>
-                <a:latin typeface="Calibri" pitchFamily="34" charset="0"/>
-                <a:ea typeface="Calibri" pitchFamily="34" charset="-122"/>
-                <a:cs typeface="Calibri" pitchFamily="34" charset="-120"/>
-              </a:rPr>
-              <a:t>  —  Service-managed session; verify the service and provider both support it</a:t>
-            </a:r>
-            <a:endParaRPr lang="en-US" sz="1600" dirty="0"/>
-          </a:p>
-          <a:p>
-            <a:pPr marL="342900" indent="-342900">
-              <a:spcAft>
-                <a:spcPts val="1000"/>
-              </a:spcAft>
-              <a:buSzPct val="100000"/>
-              <a:buChar char="•"/>
-            </a:pPr>
-            <a:r>
-              <a:rPr lang="en-US" sz="1600" b="1" dirty="0">
-                <a:solidFill>
-                  <a:srgbClr val="1E2761"/>
-                </a:solidFill>
-                <a:latin typeface="Calibri" pitchFamily="34" charset="0"/>
-                <a:ea typeface="Calibri" pitchFamily="34" charset="-122"/>
-                <a:cs typeface="Calibri" pitchFamily="34" charset="-120"/>
-              </a:rPr>
-              <a:t>Dynamic memory or policy</a:t>
-            </a:r>
-            <a:pPr indent="0" marL="0">
-              <a:spcAft>
-                <a:spcPts val="1000"/>
-              </a:spcAft>
-              <a:buNone/>
-            </a:pPr>
-            <a:r>
-              <a:rPr lang="en-US" sz="1600" dirty="0">
-                <a:solidFill>
-                  <a:srgbClr val="212121"/>
-                </a:solidFill>
-                <a:latin typeface="Calibri" pitchFamily="34" charset="0"/>
-                <a:ea typeface="Calibri" pitchFamily="34" charset="-122"/>
-                <a:cs typeface="Calibri" pitchFamily="34" charset="-120"/>
-              </a:rPr>
-              <a:t>  —  ContextProvider; verify before_run/after_run state is session-scoped</a:t>
-            </a:r>
-            <a:endParaRPr lang="en-US" sz="1600" dirty="0"/>
-          </a:p>
-          <a:p>
-            <a:pPr marL="342900" indent="-342900">
-              <a:spcAft>
-                <a:spcPts val="1000"/>
-              </a:spcAft>
-              <a:buSzPct val="100000"/>
-              <a:buChar char="•"/>
-            </a:pPr>
-            <a:r>
-              <a:rPr lang="en-US" sz="1600" b="1" dirty="0">
-                <a:solidFill>
-                  <a:srgbClr val="1E2761"/>
-                </a:solidFill>
-                <a:latin typeface="Calibri" pitchFamily="34" charset="0"/>
-                <a:ea typeface="Calibri" pitchFamily="34" charset="-122"/>
-                <a:cs typeface="Calibri" pitchFamily="34" charset="-120"/>
-              </a:rPr>
-              <a:t>Restart durability</a:t>
-            </a:r>
-            <a:pPr indent="0" marL="0">
-              <a:spcAft>
-                <a:spcPts val="1000"/>
-              </a:spcAft>
-              <a:buNone/>
-            </a:pPr>
-            <a:r>
-              <a:rPr lang="en-US" sz="1600" dirty="0">
-                <a:solidFill>
-                  <a:srgbClr val="212121"/>
-                </a:solidFill>
-                <a:latin typeface="Calibri" pitchFamily="34" charset="0"/>
-                <a:ea typeface="Calibri" pitchFamily="34" charset="-122"/>
-                <a:cs typeface="Calibri" pitchFamily="34" charset="-120"/>
-              </a:rPr>
-              <a:t>  —  App-owned persistence, or a self-host SessionStore; verify encryption, retention, and concurrency</a:t>
-            </a:r>
-            <a:endParaRPr lang="en-US" sz="1600" dirty="0"/>
-          </a:p>
-          <a:p>
-            <a:pPr marL="342900" indent="-342900">
-              <a:spcAft>
-                <a:spcPts val="1000"/>
-              </a:spcAft>
-              <a:buSzPct val="100000"/>
-              <a:buChar char="•"/>
-            </a:pPr>
-            <a:r>
-              <a:rPr lang="en-US" sz="1600" b="1" dirty="0">
-                <a:solidFill>
-                  <a:srgbClr val="1E2761"/>
-                </a:solidFill>
-                <a:latin typeface="Calibri" pitchFamily="34" charset="0"/>
-                <a:ea typeface="Calibri" pitchFamily="34" charset="-122"/>
-                <a:cs typeface="Calibri" pitchFamily="34" charset="-120"/>
-              </a:rPr>
-              <a:t>Multi-tenant resume</a:t>
-            </a:r>
-            <a:pPr indent="0" marL="0">
-              <a:spcAft>
-                <a:spcPts val="1000"/>
-              </a:spcAft>
-              <a:buNone/>
-            </a:pPr>
-            <a:r>
-              <a:rPr lang="en-US" sz="1600" dirty="0">
-                <a:solidFill>
-                  <a:srgbClr val="212121"/>
-                </a:solidFill>
-                <a:latin typeface="Calibri" pitchFamily="34" charset="0"/>
-                <a:ea typeface="Calibri" pitchFamily="34" charset="-122"/>
-                <a:cs typeface="Calibri" pitchFamily="34" charset="-120"/>
-              </a:rPr>
-              <a:t>  —  A trusted ownership mapping; verify raw service IDs are never treated as authorization</a:t>
-            </a:r>
-            <a:endParaRPr lang="en-US" sz="1600" dirty="0"/>
-          </a:p>
-        </p:txBody>
-      </p:sp>
-      <p:sp>
-        <p:nvSpPr>
-          <p:cNvPr id="6" name="Shape 4"/>
-          <p:cNvSpPr/>
-          <p:nvPr/>
-        </p:nvSpPr>
-        <p:spPr>
-          <a:xfrm>
-            <a:off x="365760" y="4773168"/>
-            <a:ext cx="8412480" cy="0"/>
-          </a:xfrm>
-          <a:prstGeom prst="line">
-            <a:avLst/>
-          </a:prstGeom>
-          <a:noFill/>
-          <a:ln w="6350">
-            <a:solidFill>
-              <a:srgbClr val="D1D5DB"/>
-            </a:solidFill>
-            <a:prstDash val="solid"/>
-          </a:ln>
-        </p:spPr>
-      </p:sp>
-      <p:sp>
-        <p:nvSpPr>
-          <p:cNvPr id="7" name="Text 5"/>
-          <p:cNvSpPr/>
-          <p:nvPr/>
-        </p:nvSpPr>
-        <p:spPr>
-          <a:xfrm>
-            <a:off x="384048" y="4818888"/>
-            <a:ext cx="8275320" cy="182880"/>
-          </a:xfrm>
-          <a:prstGeom prst="rect">
-            <a:avLst/>
-          </a:prstGeom>
-          <a:noFill/>
-          <a:ln/>
-        </p:spPr>
-        <p:txBody>
-          <a:bodyPr wrap="square" lIns="0" tIns="0" rIns="0" bIns="0" rtlCol="0" anchor="ctr">
-            <a:normAutofit/>
-          </a:bodyPr>
-          <a:lstStyle/>
-          <a:p>
-            <a:pPr indent="0" marL="0">
-              <a:buNone/>
-            </a:pPr>
-            <a:r>
-              <a:rPr lang="en-US" sz="820" dirty="0">
-                <a:solidFill>
-                  <a:srgbClr val="6B7280"/>
-                </a:solidFill>
-                <a:latin typeface="Calibri" pitchFamily="34" charset="0"/>
-                <a:ea typeface="Calibri" pitchFamily="34" charset="-122"/>
-                <a:cs typeface="Calibri" pitchFamily="34" charset="-120"/>
-              </a:rPr>
-              <a:t>Source: https://learn.microsoft.com/en-us/agent-framework/concepts/agents/conversations/session?tabs=python  ·  +1 in notes</a:t>
-            </a:r>
-            <a:endParaRPr lang="en-US" sz="820" dirty="0"/>
-          </a:p>
-        </p:txBody>
-      </p:sp>
-    </p:spTree>
-  </p:cSld>
-  <p:clrMapOvr>
-    <a:masterClrMapping/>
-  </p:clrMapOvr>
-</p:sld>
-</file>
-
-<file path=ppt/slides/slide14.xml><?xml version="1.0" encoding="utf-8"?>
-<p:sld xmlns:a="http://schemas.openxmlformats.org/drawingml/2006/main" xmlns:r="http://schemas.openxmlformats.org/officeDocument/2006/relationships" xmlns:p="http://schemas.openxmlformats.org/presentationml/2006/main">
-  <p:cSld name="Slide 14">
     <p:bg>
       <p:bgPr>
         <a:solidFill>
@@ -9281,7 +8817,7 @@
     <p:bg>
       <p:bgPr>
         <a:solidFill>
-          <a:srgbClr val="CADCFC"/>
+          <a:srgbClr val="FFFFFF"/>
         </a:solidFill>
       </p:bgPr>
     </p:bg>
@@ -9308,7 +8844,7 @@
         <p:spPr>
           <a:xfrm>
             <a:off x="0" y="0"/>
-            <a:ext cx="146304" cy="5143500"/>
+            <a:ext cx="54864" cy="5143500"/>
           </a:xfrm>
           <a:prstGeom prst="rect">
             <a:avLst/>
@@ -9327,8 +8863,8 @@
         </p:nvSpPr>
         <p:spPr>
           <a:xfrm>
-            <a:off x="5669280" y="274320"/>
-            <a:ext cx="3291840" cy="274320"/>
+            <a:off x="5486400" y="256032"/>
+            <a:ext cx="3337560" cy="228600"/>
           </a:xfrm>
           <a:prstGeom prst="rect">
             <a:avLst/>
@@ -9337,14 +8873,16 @@
           <a:ln/>
         </p:spPr>
         <p:txBody>
-          <a:bodyPr wrap="square" lIns="0" tIns="0" rIns="0" bIns="0" rtlCol="0" anchor="ctr"/>
+          <a:bodyPr wrap="square" lIns="0" tIns="0" rIns="0" bIns="0" rtlCol="0" anchor="ctr">
+            <a:normAutofit/>
+          </a:bodyPr>
           <a:lstStyle/>
           <a:p>
             <a:pPr algn="r" indent="0" marL="0">
               <a:buNone/>
             </a:pPr>
             <a:r>
-              <a:rPr lang="en-US" sz="1000" dirty="0">
+              <a:rPr lang="en-US" sz="950" dirty="0">
                 <a:solidFill>
                   <a:srgbClr val="6B7280"/>
                 </a:solidFill>
@@ -9352,9 +8890,9 @@
                 <a:ea typeface="Calibri" pitchFamily="34" charset="-122"/>
                 <a:cs typeface="Calibri" pitchFamily="34" charset="-120"/>
               </a:rPr>
-              <a:t>Day 3 · Module 1 · Demo</a:t>
-            </a:r>
-            <a:endParaRPr lang="en-US" sz="1000" dirty="0"/>
+              <a:t>Day 3 · Module 1</a:t>
+            </a:r>
+            <a:endParaRPr lang="en-US" sz="950" dirty="0"/>
           </a:p>
         </p:txBody>
       </p:sp>
@@ -9366,8 +8904,8 @@
         </p:nvSpPr>
         <p:spPr>
           <a:xfrm>
-            <a:off x="548640" y="1051560"/>
-            <a:ext cx="5486400" cy="502920"/>
+            <a:off x="365760" y="310896"/>
+            <a:ext cx="6583680" cy="603504"/>
           </a:xfrm>
           <a:prstGeom prst="rect">
             <a:avLst/>
@@ -9376,14 +8914,16 @@
           <a:ln/>
         </p:spPr>
         <p:txBody>
-          <a:bodyPr wrap="square" lIns="0" tIns="0" rIns="0" bIns="0" rtlCol="0" anchor="ctr"/>
+          <a:bodyPr wrap="square" lIns="0" tIns="0" rIns="0" bIns="0" rtlCol="0" anchor="ctr">
+            <a:normAutofit/>
+          </a:bodyPr>
           <a:lstStyle/>
           <a:p>
             <a:pPr indent="0" marL="0">
               <a:buNone/>
             </a:pPr>
             <a:r>
-              <a:rPr lang="en-US" sz="3200" b="1" spc="800" kern="0" dirty="0">
+              <a:rPr lang="en-US" sz="2500" b="1" dirty="0">
                 <a:solidFill>
                   <a:srgbClr val="1E2761"/>
                 </a:solidFill>
@@ -9391,9 +8931,9 @@
                 <a:ea typeface="Calibri" pitchFamily="34" charset="-122"/>
                 <a:cs typeface="Calibri" pitchFamily="34" charset="-120"/>
               </a:rPr>
-              <a:t>DEMO</a:t>
-            </a:r>
-            <a:endParaRPr lang="en-US" sz="3200" dirty="0"/>
+              <a:t>ContextProvider wraps each invocation</a:t>
+            </a:r>
+            <a:endParaRPr lang="en-US" sz="2500" dirty="0"/>
           </a:p>
         </p:txBody>
       </p:sp>
@@ -9405,8 +8945,8 @@
         </p:nvSpPr>
         <p:spPr>
           <a:xfrm>
-            <a:off x="548640" y="1691640"/>
-            <a:ext cx="8046720" cy="914400"/>
+            <a:off x="502920" y="1170432"/>
+            <a:ext cx="7955280" cy="3520440"/>
           </a:xfrm>
           <a:prstGeom prst="rect">
             <a:avLst/>
@@ -9415,14 +8955,20 @@
           <a:ln/>
         </p:spPr>
         <p:txBody>
-          <a:bodyPr wrap="square" lIns="0" tIns="0" rIns="0" bIns="0" rtlCol="0" anchor="ctr"/>
+          <a:bodyPr wrap="square" lIns="0" tIns="0" rIns="0" bIns="0" rtlCol="0" anchor="t">
+            <a:normAutofit/>
+          </a:bodyPr>
           <a:lstStyle/>
           <a:p>
-            <a:pPr indent="0" marL="0">
-              <a:buNone/>
-            </a:pPr>
-            <a:r>
-              <a:rPr lang="en-US" sz="3000" b="1" dirty="0">
+            <a:pPr marL="342900" indent="-342900">
+              <a:spcAft>
+                <a:spcPts val="1000"/>
+              </a:spcAft>
+              <a:buSzPct val="100000"/>
+              <a:buChar char="•"/>
+            </a:pPr>
+            <a:r>
+              <a:rPr lang="en-US" sz="1600" b="1" dirty="0">
                 <a:solidFill>
                   <a:srgbClr val="1E2761"/>
                 </a:solidFill>
@@ -9430,135 +8976,146 @@
                 <a:ea typeface="Calibri" pitchFamily="34" charset="-122"/>
                 <a:cs typeface="Calibri" pitchFamily="34" charset="-120"/>
               </a:rPr>
-              <a:t>Suspend/resume: service-managed vs. in-memory</a:t>
-            </a:r>
-            <a:endParaRPr lang="en-US" sz="3000" dirty="0"/>
+              <a:t>1. Caller input</a:t>
+            </a:r>
+            <a:pPr indent="0" marL="0">
+              <a:spcAft>
+                <a:spcPts val="1000"/>
+              </a:spcAft>
+              <a:buNone/>
+            </a:pPr>
+            <a:r>
+              <a:rPr lang="en-US" sz="1600" dirty="0">
+                <a:solidFill>
+                  <a:srgbClr val="212121"/>
+                </a:solidFill>
+                <a:latin typeface="Calibri" pitchFamily="34" charset="0"/>
+                <a:ea typeface="Calibri" pitchFamily="34" charset="-122"/>
+                <a:cs typeface="Calibri" pitchFamily="34" charset="-120"/>
+              </a:rPr>
+              <a:t>  —  Your app passes messages and session to agent.run(...)</a:t>
+            </a:r>
+            <a:endParaRPr lang="en-US" sz="1600" dirty="0"/>
+          </a:p>
+          <a:p>
+            <a:pPr marL="342900" indent="-342900">
+              <a:spcAft>
+                <a:spcPts val="1000"/>
+              </a:spcAft>
+              <a:buSzPct val="100000"/>
+              <a:buChar char="•"/>
+            </a:pPr>
+            <a:r>
+              <a:rPr lang="en-US" sz="1600" b="1" dirty="0">
+                <a:solidFill>
+                  <a:srgbClr val="1E2761"/>
+                </a:solidFill>
+                <a:latin typeface="Calibri" pitchFamily="34" charset="0"/>
+                <a:ea typeface="Calibri" pitchFamily="34" charset="-122"/>
+                <a:cs typeface="Calibri" pitchFamily="34" charset="-120"/>
+              </a:rPr>
+              <a:t>2. before_run</a:t>
+            </a:r>
+            <a:pPr indent="0" marL="0">
+              <a:spcAft>
+                <a:spcPts val="1000"/>
+              </a:spcAft>
+              <a:buNone/>
+            </a:pPr>
+            <a:r>
+              <a:rPr lang="en-US" sz="1600" dirty="0">
+                <a:solidFill>
+                  <a:srgbClr val="212121"/>
+                </a:solidFill>
+                <a:latin typeface="Calibri" pitchFamily="34" charset="0"/>
+                <a:ea typeface="Calibri" pitchFamily="34" charset="-122"/>
+                <a:cs typeface="Calibri" pitchFamily="34" charset="-120"/>
+              </a:rPr>
+              <a:t>  —  Provider can call context.extend_instructions(source_id, ...), context.extend_tools(source_id, ...), or context.extend_middleware(source_id, ...) to enrich this one invocation</a:t>
+            </a:r>
+            <a:endParaRPr lang="en-US" sz="1600" dirty="0"/>
+          </a:p>
+          <a:p>
+            <a:pPr marL="342900" indent="-342900">
+              <a:spcAft>
+                <a:spcPts val="1000"/>
+              </a:spcAft>
+              <a:buSzPct val="100000"/>
+              <a:buChar char="•"/>
+            </a:pPr>
+            <a:r>
+              <a:rPr lang="en-US" sz="1600" b="1" dirty="0">
+                <a:solidFill>
+                  <a:srgbClr val="1E2761"/>
+                </a:solidFill>
+                <a:latin typeface="Calibri" pitchFamily="34" charset="0"/>
+                <a:ea typeface="Calibri" pitchFamily="34" charset="-122"/>
+                <a:cs typeface="Calibri" pitchFamily="34" charset="-120"/>
+              </a:rPr>
+              <a:t>3. Agent execution</a:t>
+            </a:r>
+            <a:pPr indent="0" marL="0">
+              <a:spcAft>
+                <a:spcPts val="1000"/>
+              </a:spcAft>
+              <a:buNone/>
+            </a:pPr>
+            <a:r>
+              <a:rPr lang="en-US" sz="1600" dirty="0">
+                <a:solidFill>
+                  <a:srgbClr val="212121"/>
+                </a:solidFill>
+                <a:latin typeface="Calibri" pitchFamily="34" charset="0"/>
+                <a:ea typeface="Calibri" pitchFamily="34" charset="-122"/>
+                <a:cs typeface="Calibri" pitchFamily="34" charset="-120"/>
+              </a:rPr>
+              <a:t>  —  Model and tools run with the enriched instructions, tools, and middleware</a:t>
+            </a:r>
+            <a:endParaRPr lang="en-US" sz="1600" dirty="0"/>
+          </a:p>
+          <a:p>
+            <a:pPr marL="342900" indent="-342900">
+              <a:spcAft>
+                <a:spcPts val="1000"/>
+              </a:spcAft>
+              <a:buSzPct val="100000"/>
+              <a:buChar char="•"/>
+            </a:pPr>
+            <a:r>
+              <a:rPr lang="en-US" sz="1600" b="1" dirty="0">
+                <a:solidFill>
+                  <a:srgbClr val="1E2761"/>
+                </a:solidFill>
+                <a:latin typeface="Calibri" pitchFamily="34" charset="0"/>
+                <a:ea typeface="Calibri" pitchFamily="34" charset="-122"/>
+                <a:cs typeface="Calibri" pitchFamily="34" charset="-120"/>
+              </a:rPr>
+              <a:t>4. after_run</a:t>
+            </a:r>
+            <a:pPr indent="0" marL="0">
+              <a:spcAft>
+                <a:spcPts val="1000"/>
+              </a:spcAft>
+              <a:buNone/>
+            </a:pPr>
+            <a:r>
+              <a:rPr lang="en-US" sz="1600" dirty="0">
+                <a:solidFill>
+                  <a:srgbClr val="212121"/>
+                </a:solidFill>
+                <a:latin typeface="Calibri" pitchFamily="34" charset="0"/>
+                <a:ea typeface="Calibri" pitchFamily="34" charset="-122"/>
+                <a:cs typeface="Calibri" pitchFamily="34" charset="-120"/>
+              </a:rPr>
+              <a:t>  —  Provider reads context.input_messages (and the response) to decide what state to persist for next time</a:t>
+            </a:r>
+            <a:endParaRPr lang="en-US" sz="1600" dirty="0"/>
           </a:p>
         </p:txBody>
       </p:sp>
       <p:sp>
         <p:nvSpPr>
-          <p:cNvPr id="6" name="Text 4"/>
-          <p:cNvSpPr/>
-          <p:nvPr/>
-        </p:nvSpPr>
-        <p:spPr>
-          <a:xfrm>
-            <a:off x="6583680" y="1051560"/>
-            <a:ext cx="2194560" cy="502920"/>
-          </a:xfrm>
-          <a:prstGeom prst="rect">
-            <a:avLst/>
-          </a:prstGeom>
-          <a:noFill/>
-          <a:ln/>
-        </p:spPr>
-        <p:txBody>
-          <a:bodyPr wrap="square" lIns="0" tIns="0" rIns="0" bIns="0" rtlCol="0" anchor="ctr"/>
-          <a:lstStyle/>
-          <a:p>
-            <a:pPr algn="r" indent="0" marL="0">
-              <a:buNone/>
-            </a:pPr>
-            <a:r>
-              <a:rPr lang="en-US" sz="1800" i="1" dirty="0">
-                <a:solidFill>
-                  <a:srgbClr val="6B7280"/>
-                </a:solidFill>
-                <a:latin typeface="Calibri" pitchFamily="34" charset="0"/>
-                <a:ea typeface="Calibri" pitchFamily="34" charset="-122"/>
-                <a:cs typeface="Calibri" pitchFamily="34" charset="-120"/>
-              </a:rPr>
-              <a:t>~5 min</a:t>
-            </a:r>
-            <a:endParaRPr lang="en-US" sz="1800" dirty="0"/>
-          </a:p>
-        </p:txBody>
-      </p:sp>
-      <p:sp>
-        <p:nvSpPr>
-          <p:cNvPr id="7" name="Text 5"/>
-          <p:cNvSpPr/>
-          <p:nvPr/>
-        </p:nvSpPr>
-        <p:spPr>
-          <a:xfrm>
-            <a:off x="548640" y="2788920"/>
-            <a:ext cx="8046720" cy="1371600"/>
-          </a:xfrm>
-          <a:prstGeom prst="rect">
-            <a:avLst/>
-          </a:prstGeom>
-          <a:noFill/>
-          <a:ln/>
-        </p:spPr>
-        <p:txBody>
-          <a:bodyPr wrap="square" lIns="0" tIns="0" rIns="0" bIns="0" rtlCol="0" anchor="ctr"/>
-          <a:lstStyle/>
-          <a:p>
-            <a:pPr indent="0" marL="0">
-              <a:spcAft>
-                <a:spcPts val="600"/>
-              </a:spcAft>
-              <a:buNone/>
-            </a:pPr>
-            <a:r>
-              <a:rPr lang="en-US" sz="1600" dirty="0">
-                <a:solidFill>
-                  <a:srgbClr val="212121"/>
-                </a:solidFill>
-                <a:latin typeface="Calibri" pitchFamily="34" charset="0"/>
-                <a:ea typeface="Calibri" pitchFamily="34" charset="-122"/>
-                <a:cs typeface="Calibri" pitchFamily="34" charset="-120"/>
-              </a:rPr>
-              <a:t>Run the official suspend_resume_session.py sample side by side: the same suspend/resume calls behave differently depending on who owns history — Foundry's service-managed session vs. an OpenAI in-memory session — making the previous slide's local-vs-service-managed distinction concrete.</a:t>
-            </a:r>
-            <a:endParaRPr lang="en-US" sz="1600" dirty="0"/>
-          </a:p>
-        </p:txBody>
-      </p:sp>
-      <p:sp>
-        <p:nvSpPr>
-          <p:cNvPr id="8" name="Text 6"/>
-          <p:cNvSpPr/>
-          <p:nvPr/>
-        </p:nvSpPr>
-        <p:spPr>
-          <a:xfrm>
-            <a:off x="548640" y="4434840"/>
-            <a:ext cx="8046720" cy="320040"/>
-          </a:xfrm>
-          <a:prstGeom prst="rect">
-            <a:avLst/>
-          </a:prstGeom>
-          <a:noFill/>
-          <a:ln/>
-        </p:spPr>
-        <p:txBody>
-          <a:bodyPr wrap="square" lIns="0" tIns="0" rIns="0" bIns="0" rtlCol="0" anchor="ctr"/>
-          <a:lstStyle/>
-          <a:p>
-            <a:pPr indent="0" marL="0">
-              <a:buNone/>
-            </a:pPr>
-            <a:r>
-              <a:rPr lang="en-US" sz="1100" i="1" dirty="0">
-                <a:solidFill>
-                  <a:srgbClr val="6B7280"/>
-                </a:solidFill>
-                <a:latin typeface="Calibri" pitchFamily="34" charset="0"/>
-                <a:ea typeface="Calibri" pitchFamily="34" charset="-122"/>
-                <a:cs typeface="Calibri" pitchFamily="34" charset="-120"/>
-              </a:rPr>
-              <a:t>Runbook: demos/day3/module-1-demo-3-suspend-resume.md</a:t>
-            </a:r>
-            <a:endParaRPr lang="en-US" sz="1100" dirty="0"/>
-          </a:p>
-        </p:txBody>
-      </p:sp>
-      <p:sp>
-        <p:nvSpPr>
-          <p:cNvPr id="9" name="Shape 7"/>
+          <p:cNvPr id="6" name="Shape 4"/>
           <p:cNvSpPr/>
           <p:nvPr/>
         </p:nvSpPr>
@@ -9581,7 +9138,7 @@
       </p:sp>
       <p:sp>
         <p:nvSpPr>
-          <p:cNvPr id="10" name="Text 8"/>
+          <p:cNvPr id="7" name="Text 5"/>
           <p:cNvSpPr/>
           <p:nvPr/>
         </p:nvSpPr>
@@ -9614,7 +9171,7 @@
                 <a:ea typeface="Calibri" pitchFamily="34" charset="-122"/>
                 <a:cs typeface="Calibri" pitchFamily="34" charset="-120"/>
               </a:rPr>
-              <a:t>Source: https://github.com/microsoft/agent-framework/blob/main/python/samples/02-agents/conversations/suspend_resume_session.py</a:t>
+              <a:t>Source: https://learn.microsoft.com/en-us/agent-framework/concepts/agents/conversations/context-providers?tabs=python</a:t>
             </a:r>
             <a:endParaRPr lang="en-US" sz="820" dirty="0"/>
           </a:p>
@@ -9740,7 +9297,7 @@
               <a:buNone/>
             </a:pPr>
             <a:r>
-              <a:rPr lang="en-US" sz="2500" b="1" dirty="0">
+              <a:rPr lang="en-US" sz="2800" b="1" dirty="0">
                 <a:solidFill>
                   <a:srgbClr val="1E2761"/>
                 </a:solidFill>
@@ -9748,9 +9305,9 @@
                 <a:ea typeface="Calibri" pitchFamily="34" charset="-122"/>
                 <a:cs typeface="Calibri" pitchFamily="34" charset="-120"/>
               </a:rPr>
-              <a:t>ContextProvider wraps each invocation</a:t>
-            </a:r>
-            <a:endParaRPr lang="en-US" sz="2500" dirty="0"/>
+              <a:t>One provider loads messages</a:t>
+            </a:r>
+            <a:endParaRPr lang="en-US" sz="2800" dirty="0"/>
           </a:p>
         </p:txBody>
       </p:sp>
@@ -9793,7 +9350,7 @@
                 <a:ea typeface="Calibri" pitchFamily="34" charset="-122"/>
                 <a:cs typeface="Calibri" pitchFamily="34" charset="-120"/>
               </a:rPr>
-              <a:t>1. Caller input</a:t>
+              <a:t>Loader</a:t>
             </a:r>
             <a:pPr indent="0" marL="0">
               <a:spcAft>
@@ -9810,7 +9367,7 @@
                 <a:ea typeface="Calibri" pitchFamily="34" charset="-122"/>
                 <a:cs typeface="Calibri" pitchFamily="34" charset="-120"/>
               </a:rPr>
-              <a:t>  —  Your app passes messages and session to agent.run(...)</a:t>
+              <a:t>  —  Exactly one HistoryProvider is configured with load_messages=True</a:t>
             </a:r>
             <a:endParaRPr lang="en-US" sz="1600" dirty="0"/>
           </a:p>
@@ -9831,7 +9388,7 @@
                 <a:ea typeface="Calibri" pitchFamily="34" charset="-122"/>
                 <a:cs typeface="Calibri" pitchFamily="34" charset="-120"/>
               </a:rPr>
-              <a:t>2. before_run</a:t>
+              <a:t>Observers</a:t>
             </a:r>
             <a:pPr indent="0" marL="0">
               <a:spcAft>
@@ -9848,7 +9405,7 @@
                 <a:ea typeface="Calibri" pitchFamily="34" charset="-122"/>
                 <a:cs typeface="Calibri" pitchFamily="34" charset="-120"/>
               </a:rPr>
-              <a:t>  —  Provider can call context.extend_instructions(source_id, ...), context.extend_tools(source_id, ...), or context.extend_middleware(source_id, ...) to enrich this one invocation</a:t>
+              <a:t>  —  Additional history providers use load_messages=False; set store_context_messages=True so they still capture context from other providers alongside input/output</a:t>
             </a:r>
             <a:endParaRPr lang="en-US" sz="1600" dirty="0"/>
           </a:p>
@@ -9869,7 +9426,7 @@
                 <a:ea typeface="Calibri" pitchFamily="34" charset="-122"/>
                 <a:cs typeface="Calibri" pitchFamily="34" charset="-120"/>
               </a:rPr>
-              <a:t>3. Agent execution</a:t>
+              <a:t>Why one loader</a:t>
             </a:r>
             <a:pPr indent="0" marL="0">
               <a:spcAft>
@@ -9886,7 +9443,7 @@
                 <a:ea typeface="Calibri" pitchFamily="34" charset="-122"/>
                 <a:cs typeface="Calibri" pitchFamily="34" charset="-120"/>
               </a:rPr>
-              <a:t>  —  Model and tools run with the enriched instructions, tools, and middleware</a:t>
+              <a:t>  —  Two loaders can duplicate history and distort what the model sees</a:t>
             </a:r>
             <a:endParaRPr lang="en-US" sz="1600" dirty="0"/>
           </a:p>
@@ -9907,7 +9464,7 @@
                 <a:ea typeface="Calibri" pitchFamily="34" charset="-122"/>
                 <a:cs typeface="Calibri" pitchFamily="34" charset="-120"/>
               </a:rPr>
-              <a:t>4. after_run</a:t>
+              <a:t>Typical use</a:t>
             </a:r>
             <a:pPr indent="0" marL="0">
               <a:spcAft>
@@ -9924,7 +9481,7 @@
                 <a:ea typeface="Calibri" pitchFamily="34" charset="-122"/>
                 <a:cs typeface="Calibri" pitchFamily="34" charset="-120"/>
               </a:rPr>
-              <a:t>  —  Provider reads context.input_messages (and the response) to decide what state to persist for next time</a:t>
+              <a:t>  —  An audit/eval history provider that observes without affecting primary history loading</a:t>
             </a:r>
             <a:endParaRPr lang="en-US" sz="1600" dirty="0"/>
           </a:p>
@@ -9988,7 +9545,7 @@
                 <a:ea typeface="Calibri" pitchFamily="34" charset="-122"/>
                 <a:cs typeface="Calibri" pitchFamily="34" charset="-120"/>
               </a:rPr>
-              <a:t>Source: https://learn.microsoft.com/en-us/agent-framework/concepts/agents/conversations/context-providers?tabs=python</a:t>
+              <a:t>Source: https://learn.microsoft.com/en-us/agent-framework/concepts/agents/conversations/context-providers?tabs=python  ·  +1 in notes</a:t>
             </a:r>
             <a:endParaRPr lang="en-US" sz="820" dirty="0"/>
           </a:p>

</xml_diff>

<commit_message>
Fix table column-width proportions in day3.js
Column widths are now proportional to each column's longest cell
(with a 1.3in floor), matching the fix already applied to day4.js —
an even split was badly starving long-content columns (e.g. Module 7's
Available Foundry evaluators table went from even 4.6/4.6 to 1.3/7.9).

Rebuilt all 9 Day 3 decks; structural validator passed.

Co-authored-by: Copilot <223556219+Copilot@users.noreply.github.com>
</commit_message>
<xml_diff>
--- a/decks/day3/module-1-sessions-state.pptx
+++ b/decks/day3/module-1-sessions-state.pptx
@@ -8009,9 +8009,9 @@
             <a:tbl>
               <a:tblPr/>
               <a:tblGrid>
-                <a:gridCol w="2804160"/>
-                <a:gridCol w="2804160"/>
-                <a:gridCol w="2804160"/>
+                <a:gridCol w="1188720"/>
+                <a:gridCol w="4035342"/>
+                <a:gridCol w="3188418"/>
               </a:tblGrid>
               <a:tr h="658368">
                 <a:tc>

</xml_diff>